<commit_message>
fix(pitch): encurta textos para caber nas caixas (sem sobreposicao)
Ajusta o copy do pitch para o tamanho das caixas do modelo (1 linha por
topico/titulo) e reduz a fonte do corpo do slide de solucao, eliminando o
encavalamento de texto.

Co-Authored-By: Claude Opus 4.8 <noreply@anthropic.com>
Claude-Session: https://claude.ai/code/session_015ZK2Lx3VZvbaTY8r85kMgT
</commit_message>
<xml_diff>
--- a/docs/FalaInstrutor-Pitch.pptx
+++ b/docs/FalaInstrutor-Pitch.pptx
@@ -1613,7 +1613,7 @@
                 <a:ea typeface="Arial" pitchFamily="34" charset="-122"/>
                 <a:cs typeface="Arial" pitchFamily="34" charset="-120"/>
               </a:rPr>
-              <a:t>PITCH · PLATAFORMA SST</a:t>
+              <a:t>PLATAFORMA DE TREINAMENTO SST</a:t>
             </a:r>
             <a:endParaRPr lang="en-US" sz="2400" dirty="0"/>
           </a:p>
@@ -1723,7 +1723,7 @@
                 <a:ea typeface="Arial" pitchFamily="34" charset="-122"/>
                 <a:cs typeface="Arial" pitchFamily="34" charset="-120"/>
               </a:rPr>
-              <a:t>Treinamento, homologação e certificado em SST — para profissionais e empresas</a:t>
+              <a:t>Capacitação em SST</a:t>
             </a:r>
             <a:endParaRPr lang="en-US" sz="2250" dirty="0"/>
           </a:p>
@@ -2802,7 +2802,7 @@
                 <a:ea typeface="Arial" pitchFamily="34" charset="-122"/>
                 <a:cs typeface="Arial" pitchFamily="34" charset="-120"/>
               </a:rPr>
-              <a:t>Treinar nas NRs é obrigatório — e custoso</a:t>
+              <a:t>Treinar nas NRs: caro e burocrático</a:t>
             </a:r>
             <a:endParaRPr lang="en-US" sz="5100" dirty="0"/>
           </a:p>
@@ -2866,7 +2866,7 @@
                 <a:ea typeface="Arial" pitchFamily="34" charset="-122"/>
                 <a:cs typeface="Arial" pitchFamily="34" charset="-120"/>
               </a:rPr>
-              <a:t>Toda empresa é obrigada por lei a treinar a equipe nas Normas Regulamentadoras.</a:t>
+              <a:t>Treinar a equipe nas NRs é exigência legal.</a:t>
             </a:r>
             <a:endParaRPr lang="en-US" sz="2850" dirty="0"/>
           </a:p>
@@ -2930,7 +2930,7 @@
                 <a:ea typeface="Arial" pitchFamily="34" charset="-122"/>
                 <a:cs typeface="Arial" pitchFamily="34" charset="-120"/>
               </a:rPr>
-              <a:t>O treinamento presencial é caro, lento e difícil de gerenciar e comprovar.</a:t>
+              <a:t>O presencial é caro, lento e difícil de gerir.</a:t>
             </a:r>
             <a:endParaRPr lang="en-US" sz="2850" dirty="0"/>
           </a:p>
@@ -2994,7 +2994,7 @@
                 <a:ea typeface="Arial" pitchFamily="34" charset="-122"/>
                 <a:cs typeface="Arial" pitchFamily="34" charset="-120"/>
               </a:rPr>
-              <a:t>Sem conformidade vêm multas, embargos e risco real de acidentes.</a:t>
+              <a:t>Sem conformidade: multas, embargos e acidentes.</a:t>
             </a:r>
             <a:endParaRPr lang="en-US" sz="2850" dirty="0"/>
           </a:p>
@@ -3235,7 +3235,7 @@
                 <a:ea typeface="Arial" pitchFamily="34" charset="-122"/>
                 <a:cs typeface="Arial" pitchFamily="34" charset="-120"/>
               </a:rPr>
-              <a:t>Treinar, homologar e certificar — 100% online</a:t>
+              <a:t>Treinar, homologar e certificar — online</a:t>
             </a:r>
             <a:endParaRPr lang="en-US" sz="4800" dirty="0"/>
           </a:p>
@@ -3271,7 +3271,7 @@
               <a:buNone/>
             </a:pPr>
             <a:r>
-              <a:rPr lang="en-US" sz="2700" dirty="0">
+              <a:rPr lang="en-US" sz="2400" dirty="0">
                 <a:solidFill>
                   <a:srgbClr val="384655"/>
                 </a:solidFill>
@@ -3279,7 +3279,7 @@
                 <a:ea typeface="Arial" pitchFamily="34" charset="-122"/>
                 <a:cs typeface="Arial" pitchFamily="34" charset="-120"/>
               </a:rPr>
-              <a:t>A FalaInstrutor reúne cursos nas NRs, prova corrigida automaticamente, certificado válido com assinatura digital do instrutor e um painel para a empresa acompanhar a conformidade da equipe.</a:t>
+              <a:t>A FalaInstrutor reúne cursos nas NRs, prova corrigida no servidor, certificado válido com assinatura digital e painel de conformidade para a empresa.</a:t>
             </a:r>
             <a:endParaRPr lang="en-US" sz="2700" dirty="0"/>
           </a:p>
@@ -3432,7 +3432,7 @@
                 <a:ea typeface="Arial" pitchFamily="34" charset="-122"/>
                 <a:cs typeface="Arial" pitchFamily="34" charset="-120"/>
               </a:rPr>
-              <a:t>dos acidentes de trabalho são evitáveis com treinamento e medidas de controle. É exatamente o que a FalaInstrutor entrega em escala.</a:t>
+              <a:t>dos acidentes de trabalho são evitáveis com treinamento e medidas de controle adequadas.</a:t>
             </a:r>
             <a:pPr algn="l" indent="0" marL="0">
               <a:lnSpc>
@@ -3813,7 +3813,7 @@
                 <a:ea typeface="Arial" pitchFamily="34" charset="-122"/>
                 <a:cs typeface="Arial" pitchFamily="34" charset="-120"/>
               </a:rPr>
-              <a:t>Teste a demonstração: falainstrutor.onrender.com</a:t>
+              <a:t>Acesse: falainstrutor.onrender.com</a:t>
             </a:r>
             <a:endParaRPr lang="en-US" sz="2550" dirty="0"/>
           </a:p>
@@ -3877,7 +3877,7 @@
                 <a:ea typeface="Arial" pitchFamily="34" charset="-122"/>
                 <a:cs typeface="Arial" pitchFamily="34" charset="-120"/>
               </a:rPr>
-              <a:t>Capacitação para profissionais e empresas (PF e PJ)</a:t>
+              <a:t>Para profissionais e empresas (PF e PJ)</a:t>
             </a:r>
             <a:endParaRPr lang="en-US" sz="2550" dirty="0"/>
           </a:p>
@@ -4219,7 +4219,7 @@
                 <a:ea typeface="Arial" pitchFamily="34" charset="-122"/>
                 <a:cs typeface="Arial" pitchFamily="34" charset="-120"/>
               </a:rPr>
-              <a:t>Aluno: cursos, vídeos, provas e certificado no celular ou no PC.</a:t>
+              <a:t>Aluno: cursos, provas e certificado no celular.</a:t>
             </a:r>
             <a:endParaRPr lang="en-US" sz="2850" dirty="0"/>
           </a:p>
@@ -4283,7 +4283,7 @@
                 <a:ea typeface="Arial" pitchFamily="34" charset="-122"/>
                 <a:cs typeface="Arial" pitchFamily="34" charset="-120"/>
               </a:rPr>
-              <a:t>Empresa: treinamentos obrigatórios por grau de risco (NR-04) e certificados da equipe.</a:t>
+              <a:t>Empresa: treinamentos por grau de risco.</a:t>
             </a:r>
             <a:endParaRPr lang="en-US" sz="2850" dirty="0"/>
           </a:p>
@@ -4347,7 +4347,7 @@
                 <a:ea typeface="Arial" pitchFamily="34" charset="-122"/>
                 <a:cs typeface="Arial" pitchFamily="34" charset="-120"/>
               </a:rPr>
-              <a:t>Instrutor e Admin: liberação de provas, vendas, comissões e gestão completa.</a:t>
+              <a:t>Instrutor e Admin: provas, vendas e gestão.</a:t>
             </a:r>
             <a:endParaRPr lang="en-US" sz="2850" dirty="0"/>
           </a:p>

</xml_diff>

<commit_message>
feat(pitch): pitch completo (11 slides) + notas do apresentador
Melhora a apresentacao: adiciona Diferenciais, Mercado/Oportunidade e Modelo
de Negocio (clonando os layouts do modelo, imagens preservadas), atualiza a
agenda e inclui notas do apresentador (roteiro de fala) em todos os slides.

Co-Authored-By: Claude Opus 4.8 <noreply@anthropic.com>
Claude-Session: https://claude.ai/code/session_015ZK2Lx3VZvbaTY8r85kMgT
</commit_message>
<xml_diff>
--- a/docs/FalaInstrutor-Pitch.pptx
+++ b/docs/FalaInstrutor-Pitch.pptx
@@ -11,6 +11,9 @@
     <p:sldId id="259" r:id="rId5"/>
     <p:sldId id="260" r:id="rId6"/>
     <p:sldId id="263" r:id="rId14"/>
+    <p:sldId id="264" r:id="rId15"/>
+    <p:sldId id="265" r:id="rId16"/>
+    <p:sldId id="266" r:id="rId17"/>
     <p:sldId id="261" r:id="rId7"/>
     <p:sldId id="262" r:id="rId8"/>
   </p:sldIdLst>
@@ -508,10 +511,8 @@
           <a:lstStyle/>
           <a:p>
             <a:r>
-              <a:rPr lang="en-US" dirty="0"/>
-              <a:t>Abertura em blocos. Troque o título à direita.</a:t>
-            </a:r>
-            <a:endParaRPr lang="en-US" dirty="0"/>
+              <a:t>Abertura (15s). Em 1 frase: digitalizamos o treinamento obrigatório de SST — cursos nas NRs, certificado válido e gestão de conformidade para empresas.</a:t>
+            </a:r>
           </a:p>
         </p:txBody>
       </p:sp>
@@ -544,6 +545,146 @@
         <p14:creationId xmlns:p14="http://schemas.microsoft.com/office/powerpoint/2010/main" val="1024086991"/>
       </p:ext>
     </p:extLst>
+  </p:cSld>
+  <p:clrMapOvr>
+    <a:masterClrMapping/>
+  </p:clrMapOvr>
+</p:notes>
+</file>
+
+<file path=ppt/notesSlides/notesSlide10.xml><?xml version="1.0" encoding="utf-8"?>
+<p:notes xmlns:a="http://schemas.openxmlformats.org/drawingml/2006/main" xmlns:p="http://schemas.openxmlformats.org/presentationml/2006/main" xmlns:r="http://schemas.openxmlformats.org/officeDocument/2006/relationships">
+  <p:cSld>
+    <p:spTree>
+      <p:nvGrpSpPr>
+        <p:cNvPr id="1" name=""/>
+        <p:cNvGrpSpPr/>
+        <p:nvPr/>
+      </p:nvGrpSpPr>
+      <p:grpSpPr>
+        <a:xfrm>
+          <a:off x="0" y="0"/>
+          <a:ext cx="0" cy="0"/>
+          <a:chOff x="0" y="0"/>
+          <a:chExt cx="0" cy="0"/>
+        </a:xfrm>
+      </p:grpSpPr>
+      <p:sp>
+        <p:nvSpPr>
+          <p:cNvPr id="2" name="Slide Image Placeholder 1"/>
+          <p:cNvSpPr>
+            <a:spLocks noGrp="1"/>
+          </p:cNvSpPr>
+          <p:nvPr>
+            <p:ph type="sldImg" idx="2"/>
+          </p:nvPr>
+        </p:nvSpPr>
+        <p:spPr/>
+      </p:sp>
+      <p:sp>
+        <p:nvSpPr>
+          <p:cNvPr id="3" name="Notes Placeholder 2"/>
+          <p:cNvSpPr>
+            <a:spLocks noGrp="1"/>
+          </p:cNvSpPr>
+          <p:nvPr>
+            <p:ph type="body" idx="3" sz="quarter"/>
+          </p:nvPr>
+        </p:nvSpPr>
+        <p:spPr/>
+        <p:txBody>
+          <a:bodyPr/>
+          <a:lstStyle/>
+          <a:p>
+            <a:r>
+              <a:t>Mais de 20 milhões de empresas ativas no Brasil, todas com obrigações de SST. Treinamentos têm validade e reciclagem — receita recorrente.</a:t>
+            </a:r>
+          </a:p>
+        </p:txBody>
+      </p:sp>
+      <p:sp>
+        <p:nvSpPr>
+          <p:cNvPr id="4" name="Slide Number Placeholder 3"/>
+          <p:cNvSpPr>
+            <a:spLocks noGrp="1"/>
+          </p:cNvSpPr>
+          <p:nvPr>
+            <p:ph type="sldNum" idx="5" sz="quarter"/>
+          </p:nvPr>
+        </p:nvSpPr>
+        <p:spPr/>
+      </p:sp>
+    </p:spTree>
+  </p:cSld>
+  <p:clrMapOvr>
+    <a:masterClrMapping/>
+  </p:clrMapOvr>
+</p:notes>
+</file>
+
+<file path=ppt/notesSlides/notesSlide11.xml><?xml version="1.0" encoding="utf-8"?>
+<p:notes xmlns:a="http://schemas.openxmlformats.org/drawingml/2006/main" xmlns:p="http://schemas.openxmlformats.org/presentationml/2006/main" xmlns:r="http://schemas.openxmlformats.org/officeDocument/2006/relationships">
+  <p:cSld>
+    <p:spTree>
+      <p:nvGrpSpPr>
+        <p:cNvPr id="1" name=""/>
+        <p:cNvGrpSpPr/>
+        <p:nvPr/>
+      </p:nvGrpSpPr>
+      <p:grpSpPr>
+        <a:xfrm>
+          <a:off x="0" y="0"/>
+          <a:ext cx="0" cy="0"/>
+          <a:chOff x="0" y="0"/>
+          <a:chExt cx="0" cy="0"/>
+        </a:xfrm>
+      </p:grpSpPr>
+      <p:sp>
+        <p:nvSpPr>
+          <p:cNvPr id="2" name="Slide Image Placeholder 1"/>
+          <p:cNvSpPr>
+            <a:spLocks noGrp="1"/>
+          </p:cNvSpPr>
+          <p:nvPr>
+            <p:ph type="sldImg" idx="2"/>
+          </p:nvPr>
+        </p:nvSpPr>
+        <p:spPr/>
+      </p:sp>
+      <p:sp>
+        <p:nvSpPr>
+          <p:cNvPr id="3" name="Notes Placeholder 2"/>
+          <p:cNvSpPr>
+            <a:spLocks noGrp="1"/>
+          </p:cNvSpPr>
+          <p:nvPr>
+            <p:ph type="body" idx="3" sz="quarter"/>
+          </p:nvPr>
+        </p:nvSpPr>
+        <p:spPr/>
+        <p:txBody>
+          <a:bodyPr/>
+          <a:lstStyle/>
+          <a:p>
+            <a:r>
+              <a:t>Três frentes de receita: B2C (cursos avulsos), B2B (planos por empresa) e marketplace de instrutores com comissão.</a:t>
+            </a:r>
+          </a:p>
+        </p:txBody>
+      </p:sp>
+      <p:sp>
+        <p:nvSpPr>
+          <p:cNvPr id="4" name="Slide Number Placeholder 3"/>
+          <p:cNvSpPr>
+            <a:spLocks noGrp="1"/>
+          </p:cNvSpPr>
+          <p:nvPr>
+            <p:ph type="sldNum" idx="5" sz="quarter"/>
+          </p:nvPr>
+        </p:nvSpPr>
+        <p:spPr/>
+      </p:sp>
+    </p:spTree>
   </p:cSld>
   <p:clrMapOvr>
     <a:masterClrMapping/>
@@ -596,10 +737,8 @@
           <a:lstStyle/>
           <a:p>
             <a:r>
-              <a:rPr lang="en-US" dirty="0"/>
-              <a:t>Blocos do treinamento, estilo sinalização.</a:t>
-            </a:r>
-            <a:endParaRPr lang="en-US" dirty="0"/>
+              <a:t>Roteiro de ~5 min: problema, solução, produto, mercado, diferenciais, modelo e próximos passos.</a:t>
+            </a:r>
           </a:p>
         </p:txBody>
       </p:sp>
@@ -684,10 +823,8 @@
           <a:lstStyle/>
           <a:p>
             <a:r>
-              <a:rPr lang="en-US" dirty="0"/>
-              <a:t>Use entre blocos.</a:t>
-            </a:r>
-            <a:endParaRPr lang="en-US" dirty="0"/>
+              <a:t>Entrando no contexto do problema.</a:t>
+            </a:r>
           </a:p>
         </p:txBody>
       </p:sp>
@@ -772,10 +909,8 @@
           <a:lstStyle/>
           <a:p>
             <a:r>
-              <a:rPr lang="en-US" dirty="0"/>
-              <a:t>Barra lateral com número, marcadores triangulares.</a:t>
-            </a:r>
-            <a:endParaRPr lang="en-US" dirty="0"/>
+              <a:t>Treinar nas NRs é obrigação legal de toda empresa. O presencial é caro e difícil de comprovar. Sem conformidade vêm multas, embargos e acidentes — dor real, cara e recorrente.</a:t>
+            </a:r>
           </a:p>
         </p:txBody>
       </p:sp>
@@ -860,10 +995,8 @@
           <a:lstStyle/>
           <a:p>
             <a:r>
-              <a:rPr lang="en-US" dirty="0"/>
-              <a:t>Imagem à esquerda, texto à direita.</a:t>
-            </a:r>
-            <a:endParaRPr lang="en-US" dirty="0"/>
+              <a:t>Resolvemos 100% online: cursos, prova corrigida automaticamente, certificado com assinatura digital do instrutor e painel de conformidade por empresa.</a:t>
+            </a:r>
           </a:p>
         </p:txBody>
       </p:sp>
@@ -948,10 +1081,8 @@
           <a:lstStyle/>
           <a:p>
             <a:r>
-              <a:rPr lang="en-US" dirty="0"/>
-              <a:t>Dado de impacto sobre fundo navy.</a:t>
-            </a:r>
-            <a:endParaRPr lang="en-US" dirty="0"/>
+              <a:t>Reforço de impacto: treinamento previne a grande maioria dos acidentes — esse é o nosso valor central.</a:t>
+            </a:r>
           </a:p>
         </p:txBody>
       </p:sp>
@@ -1036,10 +1167,8 @@
           <a:lstStyle/>
           <a:p>
             <a:r>
-              <a:rPr lang="en-US" dirty="0"/>
-              <a:t>Fechamento e próximos passos.</a:t>
-            </a:r>
-            <a:endParaRPr lang="en-US" dirty="0"/>
+              <a:t>Convite: testar a demonstração e conversar sobre proposta. Contato na tela.</a:t>
+            </a:r>
           </a:p>
         </p:txBody>
       </p:sp>
@@ -1072,6 +1201,146 @@
         <p14:creationId xmlns:p14="http://schemas.microsoft.com/office/powerpoint/2010/main" val="1024086991"/>
       </p:ext>
     </p:extLst>
+  </p:cSld>
+  <p:clrMapOvr>
+    <a:masterClrMapping/>
+  </p:clrMapOvr>
+</p:notes>
+</file>
+
+<file path=ppt/notesSlides/notesSlide8.xml><?xml version="1.0" encoding="utf-8"?>
+<p:notes xmlns:a="http://schemas.openxmlformats.org/drawingml/2006/main" xmlns:p="http://schemas.openxmlformats.org/presentationml/2006/main" xmlns:r="http://schemas.openxmlformats.org/officeDocument/2006/relationships">
+  <p:cSld>
+    <p:spTree>
+      <p:nvGrpSpPr>
+        <p:cNvPr id="1" name=""/>
+        <p:cNvGrpSpPr/>
+        <p:nvPr/>
+      </p:nvGrpSpPr>
+      <p:grpSpPr>
+        <a:xfrm>
+          <a:off x="0" y="0"/>
+          <a:ext cx="0" cy="0"/>
+          <a:chOff x="0" y="0"/>
+          <a:chExt cx="0" cy="0"/>
+        </a:xfrm>
+      </p:grpSpPr>
+      <p:sp>
+        <p:nvSpPr>
+          <p:cNvPr id="2" name="Slide Image Placeholder 1"/>
+          <p:cNvSpPr>
+            <a:spLocks noGrp="1"/>
+          </p:cNvSpPr>
+          <p:nvPr>
+            <p:ph type="sldImg" idx="2"/>
+          </p:nvPr>
+        </p:nvSpPr>
+        <p:spPr/>
+      </p:sp>
+      <p:sp>
+        <p:nvSpPr>
+          <p:cNvPr id="3" name="Notes Placeholder 2"/>
+          <p:cNvSpPr>
+            <a:spLocks noGrp="1"/>
+          </p:cNvSpPr>
+          <p:nvPr>
+            <p:ph type="body" idx="3" sz="quarter"/>
+          </p:nvPr>
+        </p:nvSpPr>
+        <p:spPr/>
+        <p:txBody>
+          <a:bodyPr/>
+          <a:lstStyle/>
+          <a:p>
+            <a:r>
+              <a:t>Quatro painéis integrados na mesma base — web e app Android. Aluno estuda e certifica; empresa acompanha conformidade; instrutor e admin gerem provas, vendas e comissões.</a:t>
+            </a:r>
+          </a:p>
+        </p:txBody>
+      </p:sp>
+      <p:sp>
+        <p:nvSpPr>
+          <p:cNvPr id="4" name="Slide Number Placeholder 3"/>
+          <p:cNvSpPr>
+            <a:spLocks noGrp="1"/>
+          </p:cNvSpPr>
+          <p:nvPr>
+            <p:ph type="sldNum" idx="5" sz="quarter"/>
+          </p:nvPr>
+        </p:nvSpPr>
+        <p:spPr/>
+      </p:sp>
+    </p:spTree>
+  </p:cSld>
+  <p:clrMapOvr>
+    <a:masterClrMapping/>
+  </p:clrMapOvr>
+</p:notes>
+</file>
+
+<file path=ppt/notesSlides/notesSlide9.xml><?xml version="1.0" encoding="utf-8"?>
+<p:notes xmlns:a="http://schemas.openxmlformats.org/drawingml/2006/main" xmlns:p="http://schemas.openxmlformats.org/presentationml/2006/main" xmlns:r="http://schemas.openxmlformats.org/officeDocument/2006/relationships">
+  <p:cSld>
+    <p:spTree>
+      <p:nvGrpSpPr>
+        <p:cNvPr id="1" name=""/>
+        <p:cNvGrpSpPr/>
+        <p:nvPr/>
+      </p:nvGrpSpPr>
+      <p:grpSpPr>
+        <a:xfrm>
+          <a:off x="0" y="0"/>
+          <a:ext cx="0" cy="0"/>
+          <a:chOff x="0" y="0"/>
+          <a:chExt cx="0" cy="0"/>
+        </a:xfrm>
+      </p:grpSpPr>
+      <p:sp>
+        <p:nvSpPr>
+          <p:cNvPr id="2" name="Slide Image Placeholder 1"/>
+          <p:cNvSpPr>
+            <a:spLocks noGrp="1"/>
+          </p:cNvSpPr>
+          <p:nvPr>
+            <p:ph type="sldImg" idx="2"/>
+          </p:nvPr>
+        </p:nvSpPr>
+        <p:spPr/>
+      </p:sp>
+      <p:sp>
+        <p:nvSpPr>
+          <p:cNvPr id="3" name="Notes Placeholder 2"/>
+          <p:cNvSpPr>
+            <a:spLocks noGrp="1"/>
+          </p:cNvSpPr>
+          <p:nvPr>
+            <p:ph type="body" idx="3" sz="quarter"/>
+          </p:nvPr>
+        </p:nvSpPr>
+        <p:spPr/>
+        <p:txBody>
+          <a:bodyPr/>
+          <a:lstStyle/>
+          <a:p>
+            <a:r>
+              <a:t>Validade jurídica (assinatura digital/ICP), integridade da avaliação (correção no servidor + homologação do instrutor) e visão de conformidade por empresa (NR-04).</a:t>
+            </a:r>
+          </a:p>
+        </p:txBody>
+      </p:sp>
+      <p:sp>
+        <p:nvSpPr>
+          <p:cNvPr id="4" name="Slide Number Placeholder 3"/>
+          <p:cNvSpPr>
+            <a:spLocks noGrp="1"/>
+          </p:cNvSpPr>
+          <p:nvPr>
+            <p:ph type="sldNum" idx="5" sz="quarter"/>
+          </p:nvPr>
+        </p:nvSpPr>
+        <p:spPr/>
+      </p:sp>
+    </p:spTree>
   </p:cSld>
   <p:clrMapOvr>
     <a:masterClrMapping/>
@@ -1737,6 +2006,746 @@
 </p:sld>
 </file>
 
+<file path=ppt/slides/slide10.xml><?xml version="1.0" encoding="utf-8"?>
+<p:sld xmlns:a="http://schemas.openxmlformats.org/drawingml/2006/main" xmlns:p="http://schemas.openxmlformats.org/presentationml/2006/main" xmlns:r="http://schemas.openxmlformats.org/officeDocument/2006/relationships">
+  <p:cSld>
+    <p:spTree>
+      <p:nvGrpSpPr>
+        <p:cNvPr id="1" name=""/>
+        <p:cNvGrpSpPr/>
+        <p:nvPr/>
+      </p:nvGrpSpPr>
+      <p:grpSpPr/>
+      <p:sp>
+        <p:nvSpPr>
+          <p:cNvPr id="2" name="Shape 0"/>
+          <p:cNvSpPr/>
+          <p:nvPr/>
+        </p:nvSpPr>
+        <p:spPr>
+          <a:xfrm>
+            <a:off x="0" y="0"/>
+            <a:ext cx="18288000" cy="10287000"/>
+          </a:xfrm>
+          <a:prstGeom prst="rect">
+            <a:avLst/>
+          </a:prstGeom>
+          <a:solidFill>
+            <a:srgbClr val="1F2A3A"/>
+          </a:solidFill>
+          <a:ln/>
+        </p:spPr>
+      </p:sp>
+      <p:sp>
+        <p:nvSpPr>
+          <p:cNvPr id="3" name="Shape 1"/>
+          <p:cNvSpPr/>
+          <p:nvPr/>
+        </p:nvSpPr>
+        <p:spPr>
+          <a:xfrm>
+            <a:off x="1428750" y="2433770"/>
+            <a:ext cx="1524000" cy="171450"/>
+          </a:xfrm>
+          <a:prstGeom prst="rect">
+            <a:avLst/>
+          </a:prstGeom>
+          <a:solidFill>
+            <a:srgbClr val="F5B21A"/>
+          </a:solidFill>
+          <a:ln/>
+        </p:spPr>
+      </p:sp>
+      <p:sp>
+        <p:nvSpPr>
+          <p:cNvPr id="4" name="Text 2"/>
+          <p:cNvSpPr/>
+          <p:nvPr/>
+        </p:nvSpPr>
+        <p:spPr>
+          <a:xfrm>
+            <a:off x="1428750" y="2986220"/>
+            <a:ext cx="16973550" cy="2741216"/>
+          </a:xfrm>
+          <a:prstGeom prst="rect">
+            <a:avLst/>
+          </a:prstGeom>
+          <a:noFill/>
+          <a:ln/>
+        </p:spPr>
+        <p:txBody>
+          <a:bodyPr wrap="square" lIns="25400" tIns="25400" rIns="25400" bIns="25400" rtlCol="0" anchor="t">
+            <a:normAutofit/>
+          </a:bodyPr>
+          <a:lstStyle/>
+          <a:p>
+            <a:pPr algn="l" indent="0" marL="0">
+              <a:lnSpc>
+                <a:spcPct val="86000"/>
+              </a:lnSpc>
+              <a:buNone/>
+            </a:pPr>
+            <a:r>
+              <a:rPr lang="en-US" sz="24750" b="1" spc="-743" kern="0" dirty="0">
+                <a:solidFill>
+                  <a:srgbClr val="F5B21A"/>
+                </a:solidFill>
+                <a:latin typeface="Arial" pitchFamily="34" charset="0"/>
+                <a:ea typeface="Arial" pitchFamily="34" charset="-122"/>
+                <a:cs typeface="Arial" pitchFamily="34" charset="-120"/>
+              </a:rPr>
+              <a:t>+20 mi</a:t>
+            </a:r>
+            <a:endParaRPr lang="en-US" sz="24750" dirty="0"/>
+          </a:p>
+        </p:txBody>
+      </p:sp>
+      <p:sp>
+        <p:nvSpPr>
+          <p:cNvPr id="5" name="Text 3"/>
+          <p:cNvSpPr/>
+          <p:nvPr/>
+        </p:nvSpPr>
+        <p:spPr>
+          <a:xfrm>
+            <a:off x="1428750" y="6070335"/>
+            <a:ext cx="11772900" cy="1820863"/>
+          </a:xfrm>
+          <a:prstGeom prst="rect">
+            <a:avLst/>
+          </a:prstGeom>
+          <a:noFill/>
+          <a:ln/>
+        </p:spPr>
+        <p:txBody>
+          <a:bodyPr wrap="square" lIns="25400" tIns="25400" rIns="25400" bIns="25400" rtlCol="0" anchor="t">
+            <a:normAutofit/>
+          </a:bodyPr>
+          <a:lstStyle/>
+          <a:p>
+            <a:pPr algn="l" indent="0" marL="0">
+              <a:lnSpc>
+                <a:spcPct val="130000"/>
+              </a:lnSpc>
+              <a:buNone/>
+            </a:pPr>
+            <a:r>
+              <a:rPr lang="en-US" sz="3600" dirty="0">
+                <a:solidFill>
+                  <a:srgbClr val="FFFFFF"/>
+                </a:solidFill>
+                <a:latin typeface="Arial" pitchFamily="34" charset="0"/>
+                <a:ea typeface="Arial" pitchFamily="34" charset="-122"/>
+                <a:cs typeface="Arial" pitchFamily="34" charset="-120"/>
+              </a:rPr>
+              <a:t>de empresas ativas no Brasil precisam cumprir obrigações de SST — mercado recorrente e em expansão.</a:t>
+            </a:r>
+            <a:pPr algn="l" indent="0" marL="0">
+              <a:lnSpc>
+                <a:spcPct val="130000"/>
+              </a:lnSpc>
+              <a:buNone/>
+            </a:pPr>
+            <a:pPr algn="l" indent="0" marL="0">
+              <a:lnSpc>
+                <a:spcPct val="130000"/>
+              </a:lnSpc>
+              <a:buNone/>
+            </a:pPr>
+            <a:endParaRPr lang="en-US" sz="3600" dirty="0"/>
+          </a:p>
+        </p:txBody>
+      </p:sp>
+      <p:sp>
+        <p:nvSpPr>
+          <p:cNvPr id="6" name="Text 4"/>
+          <p:cNvSpPr/>
+          <p:nvPr/>
+        </p:nvSpPr>
+        <p:spPr>
+          <a:xfrm>
+            <a:off x="1428750" y="9505950"/>
+            <a:ext cx="4603406" cy="285750"/>
+          </a:xfrm>
+          <a:prstGeom prst="rect">
+            <a:avLst/>
+          </a:prstGeom>
+          <a:noFill/>
+          <a:ln/>
+        </p:spPr>
+        <p:txBody>
+          <a:bodyPr wrap="square" lIns="25400" tIns="25400" rIns="25400" bIns="25400" rtlCol="0" anchor="t">
+            <a:normAutofit/>
+          </a:bodyPr>
+          <a:lstStyle/>
+          <a:p>
+            <a:pPr algn="l" indent="0" marL="0">
+              <a:lnSpc>
+                <a:spcPct val="100000"/>
+              </a:lnSpc>
+              <a:buNone/>
+            </a:pPr>
+            <a:r>
+              <a:rPr lang="en-US" sz="1950" b="1" dirty="0">
+                <a:solidFill>
+                  <a:srgbClr val="8A94A6"/>
+                </a:solidFill>
+                <a:latin typeface="Arial" pitchFamily="34" charset="0"/>
+                <a:ea typeface="Arial" pitchFamily="34" charset="-122"/>
+                <a:cs typeface="Arial" pitchFamily="34" charset="-120"/>
+              </a:rPr>
+              <a:t>FalaInstrutor · Segurança do Trabalho</a:t>
+            </a:r>
+            <a:endParaRPr lang="en-US" sz="1950" dirty="0"/>
+          </a:p>
+        </p:txBody>
+      </p:sp>
+      <p:sp>
+        <p:nvSpPr>
+          <p:cNvPr id="7" name="Text 5"/>
+          <p:cNvSpPr/>
+          <p:nvPr/>
+        </p:nvSpPr>
+        <p:spPr>
+          <a:xfrm>
+            <a:off x="16583687" y="9505950"/>
+            <a:ext cx="351764" cy="285750"/>
+          </a:xfrm>
+          <a:prstGeom prst="rect">
+            <a:avLst/>
+          </a:prstGeom>
+          <a:noFill/>
+          <a:ln/>
+        </p:spPr>
+        <p:txBody>
+          <a:bodyPr wrap="square" lIns="25400" tIns="25400" rIns="25400" bIns="25400" rtlCol="0" anchor="t">
+            <a:normAutofit/>
+          </a:bodyPr>
+          <a:lstStyle/>
+          <a:p>
+            <a:pPr algn="l" indent="0" marL="0">
+              <a:lnSpc>
+                <a:spcPct val="100000"/>
+              </a:lnSpc>
+              <a:buNone/>
+            </a:pPr>
+            <a:r>
+              <a:rPr lang="en-US" sz="1950" b="1" dirty="0">
+                <a:solidFill>
+                  <a:srgbClr val="8A94A6"/>
+                </a:solidFill>
+                <a:latin typeface="Arial" pitchFamily="34" charset="0"/>
+                <a:ea typeface="Arial" pitchFamily="34" charset="-122"/>
+                <a:cs typeface="Arial" pitchFamily="34" charset="-120"/>
+              </a:rPr>
+              <a:t>08</a:t>
+            </a:r>
+            <a:endParaRPr lang="en-US" sz="1950" dirty="0"/>
+          </a:p>
+        </p:txBody>
+      </p:sp>
+    </p:spTree>
+  </p:cSld>
+  <p:clrMapOvr>
+    <a:masterClrMapping/>
+  </p:clrMapOvr>
+</p:sld>
+</file>
+
+<file path=ppt/slides/slide11.xml><?xml version="1.0" encoding="utf-8"?>
+<p:sld xmlns:a="http://schemas.openxmlformats.org/drawingml/2006/main" xmlns:p="http://schemas.openxmlformats.org/presentationml/2006/main" xmlns:r="http://schemas.openxmlformats.org/officeDocument/2006/relationships">
+  <p:cSld>
+    <p:spTree>
+      <p:nvGrpSpPr>
+        <p:cNvPr id="1" name=""/>
+        <p:cNvGrpSpPr/>
+        <p:nvPr/>
+      </p:nvGrpSpPr>
+      <p:grpSpPr/>
+      <p:sp>
+        <p:nvSpPr>
+          <p:cNvPr id="2" name="Shape 0"/>
+          <p:cNvSpPr/>
+          <p:nvPr/>
+        </p:nvSpPr>
+        <p:spPr>
+          <a:xfrm>
+            <a:off x="0" y="0"/>
+            <a:ext cx="18288000" cy="10287000"/>
+          </a:xfrm>
+          <a:prstGeom prst="rect">
+            <a:avLst/>
+          </a:prstGeom>
+          <a:solidFill>
+            <a:srgbClr val="FFFFFF"/>
+          </a:solidFill>
+          <a:ln/>
+        </p:spPr>
+      </p:sp>
+      <p:sp>
+        <p:nvSpPr>
+          <p:cNvPr id="3" name="Shape 1"/>
+          <p:cNvSpPr/>
+          <p:nvPr/>
+        </p:nvSpPr>
+        <p:spPr>
+          <a:xfrm>
+            <a:off x="0" y="0"/>
+            <a:ext cx="4000500" cy="10287000"/>
+          </a:xfrm>
+          <a:prstGeom prst="rect">
+            <a:avLst/>
+          </a:prstGeom>
+          <a:solidFill>
+            <a:srgbClr val="1F2A3A"/>
+          </a:solidFill>
+          <a:ln/>
+        </p:spPr>
+      </p:sp>
+      <p:sp>
+        <p:nvSpPr>
+          <p:cNvPr id="4" name="Text 2"/>
+          <p:cNvSpPr/>
+          <p:nvPr/>
+        </p:nvSpPr>
+        <p:spPr>
+          <a:xfrm>
+            <a:off x="533400" y="1238250"/>
+            <a:ext cx="3227070" cy="1752600"/>
+          </a:xfrm>
+          <a:prstGeom prst="rect">
+            <a:avLst/>
+          </a:prstGeom>
+          <a:noFill/>
+          <a:ln/>
+        </p:spPr>
+        <p:txBody>
+          <a:bodyPr wrap="square" lIns="25400" tIns="25400" rIns="25400" bIns="25400" rtlCol="0" anchor="t">
+            <a:normAutofit/>
+          </a:bodyPr>
+          <a:lstStyle/>
+          <a:p>
+            <a:pPr algn="l" indent="0" marL="0">
+              <a:lnSpc>
+                <a:spcPct val="100000"/>
+              </a:lnSpc>
+              <a:buNone/>
+            </a:pPr>
+            <a:r>
+              <a:rPr lang="en-US" sz="13500" b="1" dirty="0">
+                <a:solidFill>
+                  <a:srgbClr val="F5B21A"/>
+                </a:solidFill>
+                <a:latin typeface="Arial" pitchFamily="34" charset="0"/>
+                <a:ea typeface="Arial" pitchFamily="34" charset="-122"/>
+                <a:cs typeface="Arial" pitchFamily="34" charset="-120"/>
+              </a:rPr>
+              <a:t>04</a:t>
+            </a:r>
+            <a:endParaRPr lang="en-US" sz="13500" dirty="0"/>
+          </a:p>
+        </p:txBody>
+      </p:sp>
+      <p:sp>
+        <p:nvSpPr>
+          <p:cNvPr id="5" name="Text 3"/>
+          <p:cNvSpPr/>
+          <p:nvPr/>
+        </p:nvSpPr>
+        <p:spPr>
+          <a:xfrm>
+            <a:off x="533400" y="3181350"/>
+            <a:ext cx="3021711" cy="967581"/>
+          </a:xfrm>
+          <a:prstGeom prst="rect">
+            <a:avLst/>
+          </a:prstGeom>
+          <a:noFill/>
+          <a:ln/>
+        </p:spPr>
+        <p:txBody>
+          <a:bodyPr wrap="square" lIns="25400" tIns="25400" rIns="25400" bIns="25400" rtlCol="0" anchor="t">
+            <a:normAutofit/>
+          </a:bodyPr>
+          <a:lstStyle/>
+          <a:p>
+            <a:pPr algn="l" indent="0" marL="0">
+              <a:lnSpc>
+                <a:spcPct val="122000"/>
+              </a:lnSpc>
+              <a:buNone/>
+            </a:pPr>
+            <a:r>
+              <a:rPr lang="en-US" sz="3000" b="1" spc="60" kern="0" dirty="0">
+                <a:solidFill>
+                  <a:srgbClr val="FFFFFF"/>
+                </a:solidFill>
+                <a:latin typeface="Arial" pitchFamily="34" charset="0"/>
+                <a:ea typeface="Arial" pitchFamily="34" charset="-122"/>
+                <a:cs typeface="Arial" pitchFamily="34" charset="-120"/>
+              </a:rPr>
+              <a:t>MODELO DE NEGÓCIO</a:t>
+            </a:r>
+            <a:endParaRPr lang="en-US" sz="3000" dirty="0"/>
+          </a:p>
+        </p:txBody>
+      </p:sp>
+      <p:pic>
+        <p:nvPicPr>
+          <p:cNvPr id="6" name="Image 0" descr="preencoded.png">    </p:cNvPr>
+          <p:cNvPicPr>
+            <a:picLocks noChangeAspect="1"/>
+          </p:cNvPicPr>
+          <p:nvPr/>
+        </p:nvPicPr>
+        <p:blipFill>
+          <a:blip r:embed="rId2"/>
+          <a:stretch>
+            <a:fillRect/>
+          </a:stretch>
+        </p:blipFill>
+        <p:spPr>
+          <a:xfrm>
+            <a:off x="533400" y="8267700"/>
+            <a:ext cx="1143000" cy="1257300"/>
+          </a:xfrm>
+          <a:prstGeom prst="rect">
+            <a:avLst/>
+          </a:prstGeom>
+        </p:spPr>
+      </p:pic>
+      <p:sp>
+        <p:nvSpPr>
+          <p:cNvPr id="7" name="Text 4"/>
+          <p:cNvSpPr/>
+          <p:nvPr/>
+        </p:nvSpPr>
+        <p:spPr>
+          <a:xfrm>
+            <a:off x="5048250" y="1238250"/>
+            <a:ext cx="12557760" cy="1436952"/>
+          </a:xfrm>
+          <a:prstGeom prst="rect">
+            <a:avLst/>
+          </a:prstGeom>
+          <a:noFill/>
+          <a:ln/>
+        </p:spPr>
+        <p:txBody>
+          <a:bodyPr wrap="square" lIns="25400" tIns="25400" rIns="25400" bIns="25400" rtlCol="0" anchor="t">
+            <a:normAutofit/>
+          </a:bodyPr>
+          <a:lstStyle/>
+          <a:p>
+            <a:pPr algn="l" indent="0" marL="0">
+              <a:lnSpc>
+                <a:spcPct val="108000"/>
+              </a:lnSpc>
+              <a:buNone/>
+            </a:pPr>
+            <a:r>
+              <a:rPr lang="en-US" sz="5100" b="1" spc="-76" kern="0" dirty="0">
+                <a:solidFill>
+                  <a:srgbClr val="1F2A3A"/>
+                </a:solidFill>
+                <a:latin typeface="Arial" pitchFamily="34" charset="0"/>
+                <a:ea typeface="Arial" pitchFamily="34" charset="-122"/>
+                <a:cs typeface="Arial" pitchFamily="34" charset="-120"/>
+              </a:rPr>
+              <a:t>Como geramos receita</a:t>
+            </a:r>
+            <a:endParaRPr lang="en-US" sz="5100" dirty="0"/>
+          </a:p>
+        </p:txBody>
+      </p:sp>
+      <p:sp>
+        <p:nvSpPr>
+          <p:cNvPr id="8" name="Shape 5"/>
+          <p:cNvSpPr/>
+          <p:nvPr/>
+        </p:nvSpPr>
+        <p:spPr>
+          <a:xfrm>
+            <a:off x="5048250" y="3303852"/>
+            <a:ext cx="209550" cy="209550"/>
+          </a:xfrm>
+          <a:prstGeom prst="rect">
+            <a:avLst/>
+          </a:prstGeom>
+          <a:solidFill>
+            <a:srgbClr val="F5B21A"/>
+          </a:solidFill>
+          <a:ln/>
+        </p:spPr>
+      </p:sp>
+      <p:sp>
+        <p:nvSpPr>
+          <p:cNvPr id="9" name="Text 6"/>
+          <p:cNvSpPr/>
+          <p:nvPr/>
+        </p:nvSpPr>
+        <p:spPr>
+          <a:xfrm>
+            <a:off x="5505450" y="3170502"/>
+            <a:ext cx="10366031" cy="552053"/>
+          </a:xfrm>
+          <a:prstGeom prst="rect">
+            <a:avLst/>
+          </a:prstGeom>
+          <a:noFill/>
+          <a:ln/>
+        </p:spPr>
+        <p:txBody>
+          <a:bodyPr wrap="square" lIns="25400" tIns="25400" rIns="25400" bIns="25400" rtlCol="0" anchor="t">
+            <a:normAutofit/>
+          </a:bodyPr>
+          <a:lstStyle/>
+          <a:p>
+            <a:pPr algn="l" indent="0" marL="0">
+              <a:lnSpc>
+                <a:spcPct val="142000"/>
+              </a:lnSpc>
+              <a:buNone/>
+            </a:pPr>
+            <a:r>
+              <a:rPr lang="en-US" sz="2850" dirty="0">
+                <a:solidFill>
+                  <a:srgbClr val="384655"/>
+                </a:solidFill>
+                <a:latin typeface="Arial" pitchFamily="34" charset="0"/>
+                <a:ea typeface="Arial" pitchFamily="34" charset="-122"/>
+                <a:cs typeface="Arial" pitchFamily="34" charset="-120"/>
+              </a:rPr>
+              <a:t>B2C: cursos avulsos para profissionais.</a:t>
+            </a:r>
+            <a:endParaRPr lang="en-US" sz="2850" dirty="0"/>
+          </a:p>
+        </p:txBody>
+      </p:sp>
+      <p:sp>
+        <p:nvSpPr>
+          <p:cNvPr id="10" name="Shape 7"/>
+          <p:cNvSpPr/>
+          <p:nvPr/>
+        </p:nvSpPr>
+        <p:spPr>
+          <a:xfrm>
+            <a:off x="5048250" y="4141655"/>
+            <a:ext cx="209550" cy="209550"/>
+          </a:xfrm>
+          <a:prstGeom prst="rect">
+            <a:avLst/>
+          </a:prstGeom>
+          <a:solidFill>
+            <a:srgbClr val="F5B21A"/>
+          </a:solidFill>
+          <a:ln/>
+        </p:spPr>
+      </p:sp>
+      <p:sp>
+        <p:nvSpPr>
+          <p:cNvPr id="11" name="Text 8"/>
+          <p:cNvSpPr/>
+          <p:nvPr/>
+        </p:nvSpPr>
+        <p:spPr>
+          <a:xfrm>
+            <a:off x="5505450" y="4008305"/>
+            <a:ext cx="8202282" cy="552053"/>
+          </a:xfrm>
+          <a:prstGeom prst="rect">
+            <a:avLst/>
+          </a:prstGeom>
+          <a:noFill/>
+          <a:ln/>
+        </p:spPr>
+        <p:txBody>
+          <a:bodyPr wrap="square" lIns="25400" tIns="25400" rIns="25400" bIns="25400" rtlCol="0" anchor="t">
+            <a:normAutofit/>
+          </a:bodyPr>
+          <a:lstStyle/>
+          <a:p>
+            <a:pPr algn="l" indent="0" marL="0">
+              <a:lnSpc>
+                <a:spcPct val="142000"/>
+              </a:lnSpc>
+              <a:buNone/>
+            </a:pPr>
+            <a:r>
+              <a:rPr lang="en-US" sz="2850" dirty="0">
+                <a:solidFill>
+                  <a:srgbClr val="384655"/>
+                </a:solidFill>
+                <a:latin typeface="Arial" pitchFamily="34" charset="0"/>
+                <a:ea typeface="Arial" pitchFamily="34" charset="-122"/>
+                <a:cs typeface="Arial" pitchFamily="34" charset="-120"/>
+              </a:rPr>
+              <a:t>B2B: planos para empresas treinarem equipes.</a:t>
+            </a:r>
+            <a:endParaRPr lang="en-US" sz="2850" dirty="0"/>
+          </a:p>
+        </p:txBody>
+      </p:sp>
+      <p:sp>
+        <p:nvSpPr>
+          <p:cNvPr id="12" name="Shape 9"/>
+          <p:cNvSpPr/>
+          <p:nvPr/>
+        </p:nvSpPr>
+        <p:spPr>
+          <a:xfrm>
+            <a:off x="5048250" y="4979458"/>
+            <a:ext cx="209550" cy="209550"/>
+          </a:xfrm>
+          <a:prstGeom prst="rect">
+            <a:avLst/>
+          </a:prstGeom>
+          <a:solidFill>
+            <a:srgbClr val="F5B21A"/>
+          </a:solidFill>
+          <a:ln/>
+        </p:spPr>
+      </p:sp>
+      <p:sp>
+        <p:nvSpPr>
+          <p:cNvPr id="13" name="Text 10"/>
+          <p:cNvSpPr/>
+          <p:nvPr/>
+        </p:nvSpPr>
+        <p:spPr>
+          <a:xfrm>
+            <a:off x="5505450" y="4846108"/>
+            <a:ext cx="10095217" cy="552053"/>
+          </a:xfrm>
+          <a:prstGeom prst="rect">
+            <a:avLst/>
+          </a:prstGeom>
+          <a:noFill/>
+          <a:ln/>
+        </p:spPr>
+        <p:txBody>
+          <a:bodyPr wrap="square" lIns="25400" tIns="25400" rIns="25400" bIns="25400" rtlCol="0" anchor="t">
+            <a:normAutofit/>
+          </a:bodyPr>
+          <a:lstStyle/>
+          <a:p>
+            <a:pPr algn="l" indent="0" marL="0">
+              <a:lnSpc>
+                <a:spcPct val="142000"/>
+              </a:lnSpc>
+              <a:buNone/>
+            </a:pPr>
+            <a:r>
+              <a:rPr lang="en-US" sz="2850" dirty="0">
+                <a:solidFill>
+                  <a:srgbClr val="384655"/>
+                </a:solidFill>
+                <a:latin typeface="Arial" pitchFamily="34" charset="0"/>
+                <a:ea typeface="Arial" pitchFamily="34" charset="-122"/>
+                <a:cs typeface="Arial" pitchFamily="34" charset="-120"/>
+              </a:rPr>
+              <a:t>Marketplace: instrutores com comissão.</a:t>
+            </a:r>
+            <a:endParaRPr lang="en-US" sz="2850" dirty="0"/>
+          </a:p>
+        </p:txBody>
+      </p:sp>
+      <p:sp>
+        <p:nvSpPr>
+          <p:cNvPr id="14" name="Text 11"/>
+          <p:cNvSpPr/>
+          <p:nvPr/>
+        </p:nvSpPr>
+        <p:spPr>
+          <a:xfrm>
+            <a:off x="5048250" y="9505950"/>
+            <a:ext cx="4603406" cy="285750"/>
+          </a:xfrm>
+          <a:prstGeom prst="rect">
+            <a:avLst/>
+          </a:prstGeom>
+          <a:noFill/>
+          <a:ln/>
+        </p:spPr>
+        <p:txBody>
+          <a:bodyPr wrap="square" lIns="25400" tIns="25400" rIns="25400" bIns="25400" rtlCol="0" anchor="t">
+            <a:normAutofit/>
+          </a:bodyPr>
+          <a:lstStyle/>
+          <a:p>
+            <a:pPr algn="l" indent="0" marL="0">
+              <a:lnSpc>
+                <a:spcPct val="100000"/>
+              </a:lnSpc>
+              <a:buNone/>
+            </a:pPr>
+            <a:r>
+              <a:rPr lang="en-US" sz="1950" b="1" dirty="0">
+                <a:solidFill>
+                  <a:srgbClr val="8A94A6"/>
+                </a:solidFill>
+                <a:latin typeface="Arial" pitchFamily="34" charset="0"/>
+                <a:ea typeface="Arial" pitchFamily="34" charset="-122"/>
+                <a:cs typeface="Arial" pitchFamily="34" charset="-120"/>
+              </a:rPr>
+              <a:t>FalaInstrutor · Segurança do Trabalho</a:t>
+            </a:r>
+            <a:endParaRPr lang="en-US" sz="1950" dirty="0"/>
+          </a:p>
+        </p:txBody>
+      </p:sp>
+      <p:sp>
+        <p:nvSpPr>
+          <p:cNvPr id="15" name="Text 12"/>
+          <p:cNvSpPr/>
+          <p:nvPr/>
+        </p:nvSpPr>
+        <p:spPr>
+          <a:xfrm>
+            <a:off x="17155187" y="9505950"/>
+            <a:ext cx="351764" cy="285750"/>
+          </a:xfrm>
+          <a:prstGeom prst="rect">
+            <a:avLst/>
+          </a:prstGeom>
+          <a:noFill/>
+          <a:ln/>
+        </p:spPr>
+        <p:txBody>
+          <a:bodyPr wrap="square" lIns="25400" tIns="25400" rIns="25400" bIns="25400" rtlCol="0" anchor="t">
+            <a:normAutofit/>
+          </a:bodyPr>
+          <a:lstStyle/>
+          <a:p>
+            <a:pPr algn="l" indent="0" marL="0">
+              <a:lnSpc>
+                <a:spcPct val="100000"/>
+              </a:lnSpc>
+              <a:buNone/>
+            </a:pPr>
+            <a:r>
+              <a:rPr lang="en-US" sz="1950" b="1" dirty="0">
+                <a:solidFill>
+                  <a:srgbClr val="8A94A6"/>
+                </a:solidFill>
+                <a:latin typeface="Arial" pitchFamily="34" charset="0"/>
+                <a:ea typeface="Arial" pitchFamily="34" charset="-122"/>
+                <a:cs typeface="Arial" pitchFamily="34" charset="-120"/>
+              </a:rPr>
+              <a:t>09</a:t>
+            </a:r>
+            <a:endParaRPr lang="en-US" sz="1950" dirty="0"/>
+          </a:p>
+        </p:txBody>
+      </p:sp>
+    </p:spTree>
+  </p:cSld>
+  <p:clrMapOvr>
+    <a:masterClrMapping/>
+  </p:clrMapOvr>
+</p:sld>
+</file>
+
 <file path=ppt/slides/slide2.xml><?xml version="1.0" encoding="utf-8"?>
 <p:sld xmlns:a="http://schemas.openxmlformats.org/drawingml/2006/main" xmlns:r="http://schemas.openxmlformats.org/officeDocument/2006/relationships" xmlns:p="http://schemas.openxmlformats.org/presentationml/2006/main">
   <p:cSld name="Slide 2">
@@ -2088,7 +3097,7 @@
                 <a:ea typeface="Arial" pitchFamily="34" charset="-122"/>
                 <a:cs typeface="Arial" pitchFamily="34" charset="-120"/>
               </a:rPr>
-              <a:t>A solução</a:t>
+              <a:t>Solução e produto</a:t>
             </a:r>
             <a:endParaRPr lang="en-US" sz="2850" dirty="0"/>
           </a:p>
@@ -2216,7 +3225,7 @@
                 <a:ea typeface="Arial" pitchFamily="34" charset="-122"/>
                 <a:cs typeface="Arial" pitchFamily="34" charset="-120"/>
               </a:rPr>
-              <a:t>O produto</a:t>
+              <a:t>Mercado e diferenciais</a:t>
             </a:r>
             <a:endParaRPr lang="en-US" sz="2850" dirty="0"/>
           </a:p>
@@ -2344,7 +3353,7 @@
                 <a:ea typeface="Arial" pitchFamily="34" charset="-122"/>
                 <a:cs typeface="Arial" pitchFamily="34" charset="-120"/>
               </a:rPr>
-              <a:t>Próximos passos</a:t>
+              <a:t>Modelo e próximos passos</a:t>
             </a:r>
             <a:endParaRPr lang="en-US" sz="2850" dirty="0"/>
           </a:p>
@@ -3532,7 +4541,7 @@
                 <a:ea typeface="Arial" pitchFamily="34" charset="-122"/>
                 <a:cs typeface="Arial" pitchFamily="34" charset="-120"/>
               </a:rPr>
-              <a:t>07</a:t>
+              <a:t>10</a:t>
             </a:r>
             <a:endParaRPr lang="en-US" sz="1950" dirty="0"/>
           </a:p>
@@ -4436,6 +5445,500 @@
                 <a:cs typeface="Arial" pitchFamily="34" charset="-120"/>
               </a:rPr>
               <a:t>06</a:t>
+            </a:r>
+            <a:endParaRPr lang="en-US" sz="1950" dirty="0"/>
+          </a:p>
+        </p:txBody>
+      </p:sp>
+    </p:spTree>
+  </p:cSld>
+  <p:clrMapOvr>
+    <a:masterClrMapping/>
+  </p:clrMapOvr>
+</p:sld>
+</file>
+
+<file path=ppt/slides/slide9.xml><?xml version="1.0" encoding="utf-8"?>
+<p:sld xmlns:a="http://schemas.openxmlformats.org/drawingml/2006/main" xmlns:p="http://schemas.openxmlformats.org/presentationml/2006/main" xmlns:r="http://schemas.openxmlformats.org/officeDocument/2006/relationships">
+  <p:cSld>
+    <p:spTree>
+      <p:nvGrpSpPr>
+        <p:cNvPr id="1" name=""/>
+        <p:cNvGrpSpPr/>
+        <p:nvPr/>
+      </p:nvGrpSpPr>
+      <p:grpSpPr/>
+      <p:sp>
+        <p:nvSpPr>
+          <p:cNvPr id="2" name="Shape 0"/>
+          <p:cNvSpPr/>
+          <p:nvPr/>
+        </p:nvSpPr>
+        <p:spPr>
+          <a:xfrm>
+            <a:off x="0" y="0"/>
+            <a:ext cx="18288000" cy="10287000"/>
+          </a:xfrm>
+          <a:prstGeom prst="rect">
+            <a:avLst/>
+          </a:prstGeom>
+          <a:solidFill>
+            <a:srgbClr val="FFFFFF"/>
+          </a:solidFill>
+          <a:ln/>
+        </p:spPr>
+      </p:sp>
+      <p:sp>
+        <p:nvSpPr>
+          <p:cNvPr id="3" name="Shape 1"/>
+          <p:cNvSpPr/>
+          <p:nvPr/>
+        </p:nvSpPr>
+        <p:spPr>
+          <a:xfrm>
+            <a:off x="0" y="0"/>
+            <a:ext cx="4000500" cy="10287000"/>
+          </a:xfrm>
+          <a:prstGeom prst="rect">
+            <a:avLst/>
+          </a:prstGeom>
+          <a:solidFill>
+            <a:srgbClr val="1F2A3A"/>
+          </a:solidFill>
+          <a:ln/>
+        </p:spPr>
+      </p:sp>
+      <p:sp>
+        <p:nvSpPr>
+          <p:cNvPr id="4" name="Text 2"/>
+          <p:cNvSpPr/>
+          <p:nvPr/>
+        </p:nvSpPr>
+        <p:spPr>
+          <a:xfrm>
+            <a:off x="533400" y="1238250"/>
+            <a:ext cx="3227070" cy="1752600"/>
+          </a:xfrm>
+          <a:prstGeom prst="rect">
+            <a:avLst/>
+          </a:prstGeom>
+          <a:noFill/>
+          <a:ln/>
+        </p:spPr>
+        <p:txBody>
+          <a:bodyPr wrap="square" lIns="25400" tIns="25400" rIns="25400" bIns="25400" rtlCol="0" anchor="t">
+            <a:normAutofit/>
+          </a:bodyPr>
+          <a:lstStyle/>
+          <a:p>
+            <a:pPr algn="l" indent="0" marL="0">
+              <a:lnSpc>
+                <a:spcPct val="100000"/>
+              </a:lnSpc>
+              <a:buNone/>
+            </a:pPr>
+            <a:r>
+              <a:rPr lang="en-US" sz="13500" b="1" dirty="0">
+                <a:solidFill>
+                  <a:srgbClr val="F5B21A"/>
+                </a:solidFill>
+                <a:latin typeface="Arial" pitchFamily="34" charset="0"/>
+                <a:ea typeface="Arial" pitchFamily="34" charset="-122"/>
+                <a:cs typeface="Arial" pitchFamily="34" charset="-120"/>
+              </a:rPr>
+              <a:t>03</a:t>
+            </a:r>
+            <a:endParaRPr lang="en-US" sz="13500" dirty="0"/>
+          </a:p>
+        </p:txBody>
+      </p:sp>
+      <p:sp>
+        <p:nvSpPr>
+          <p:cNvPr id="5" name="Text 3"/>
+          <p:cNvSpPr/>
+          <p:nvPr/>
+        </p:nvSpPr>
+        <p:spPr>
+          <a:xfrm>
+            <a:off x="533400" y="3181350"/>
+            <a:ext cx="3021711" cy="967581"/>
+          </a:xfrm>
+          <a:prstGeom prst="rect">
+            <a:avLst/>
+          </a:prstGeom>
+          <a:noFill/>
+          <a:ln/>
+        </p:spPr>
+        <p:txBody>
+          <a:bodyPr wrap="square" lIns="25400" tIns="25400" rIns="25400" bIns="25400" rtlCol="0" anchor="t">
+            <a:normAutofit/>
+          </a:bodyPr>
+          <a:lstStyle/>
+          <a:p>
+            <a:pPr algn="l" indent="0" marL="0">
+              <a:lnSpc>
+                <a:spcPct val="122000"/>
+              </a:lnSpc>
+              <a:buNone/>
+            </a:pPr>
+            <a:r>
+              <a:rPr lang="en-US" sz="3000" b="1" spc="60" kern="0" dirty="0">
+                <a:solidFill>
+                  <a:srgbClr val="FFFFFF"/>
+                </a:solidFill>
+                <a:latin typeface="Arial" pitchFamily="34" charset="0"/>
+                <a:ea typeface="Arial" pitchFamily="34" charset="-122"/>
+                <a:cs typeface="Arial" pitchFamily="34" charset="-120"/>
+              </a:rPr>
+              <a:t>DIFERENCIAIS</a:t>
+            </a:r>
+            <a:endParaRPr lang="en-US" sz="3000" dirty="0"/>
+          </a:p>
+        </p:txBody>
+      </p:sp>
+      <p:pic>
+        <p:nvPicPr>
+          <p:cNvPr id="6" name="Image 0" descr="preencoded.png">    </p:cNvPr>
+          <p:cNvPicPr>
+            <a:picLocks noChangeAspect="1"/>
+          </p:cNvPicPr>
+          <p:nvPr/>
+        </p:nvPicPr>
+        <p:blipFill>
+          <a:blip r:embed="rId2"/>
+          <a:stretch>
+            <a:fillRect/>
+          </a:stretch>
+        </p:blipFill>
+        <p:spPr>
+          <a:xfrm>
+            <a:off x="533400" y="8267700"/>
+            <a:ext cx="1143000" cy="1257300"/>
+          </a:xfrm>
+          <a:prstGeom prst="rect">
+            <a:avLst/>
+          </a:prstGeom>
+        </p:spPr>
+      </p:pic>
+      <p:sp>
+        <p:nvSpPr>
+          <p:cNvPr id="7" name="Text 4"/>
+          <p:cNvSpPr/>
+          <p:nvPr/>
+        </p:nvSpPr>
+        <p:spPr>
+          <a:xfrm>
+            <a:off x="5048250" y="1238250"/>
+            <a:ext cx="12557760" cy="1436952"/>
+          </a:xfrm>
+          <a:prstGeom prst="rect">
+            <a:avLst/>
+          </a:prstGeom>
+          <a:noFill/>
+          <a:ln/>
+        </p:spPr>
+        <p:txBody>
+          <a:bodyPr wrap="square" lIns="25400" tIns="25400" rIns="25400" bIns="25400" rtlCol="0" anchor="t">
+            <a:normAutofit/>
+          </a:bodyPr>
+          <a:lstStyle/>
+          <a:p>
+            <a:pPr algn="l" indent="0" marL="0">
+              <a:lnSpc>
+                <a:spcPct val="108000"/>
+              </a:lnSpc>
+              <a:buNone/>
+            </a:pPr>
+            <a:r>
+              <a:rPr lang="en-US" sz="5100" b="1" spc="-76" kern="0" dirty="0">
+                <a:solidFill>
+                  <a:srgbClr val="1F2A3A"/>
+                </a:solidFill>
+                <a:latin typeface="Arial" pitchFamily="34" charset="0"/>
+                <a:ea typeface="Arial" pitchFamily="34" charset="-122"/>
+                <a:cs typeface="Arial" pitchFamily="34" charset="-120"/>
+              </a:rPr>
+              <a:t>Por que a FalaInstrutor</a:t>
+            </a:r>
+            <a:endParaRPr lang="en-US" sz="5100" dirty="0"/>
+          </a:p>
+        </p:txBody>
+      </p:sp>
+      <p:sp>
+        <p:nvSpPr>
+          <p:cNvPr id="8" name="Shape 5"/>
+          <p:cNvSpPr/>
+          <p:nvPr/>
+        </p:nvSpPr>
+        <p:spPr>
+          <a:xfrm>
+            <a:off x="5048250" y="3303852"/>
+            <a:ext cx="209550" cy="209550"/>
+          </a:xfrm>
+          <a:prstGeom prst="rect">
+            <a:avLst/>
+          </a:prstGeom>
+          <a:solidFill>
+            <a:srgbClr val="F5B21A"/>
+          </a:solidFill>
+          <a:ln/>
+        </p:spPr>
+      </p:sp>
+      <p:sp>
+        <p:nvSpPr>
+          <p:cNvPr id="9" name="Text 6"/>
+          <p:cNvSpPr/>
+          <p:nvPr/>
+        </p:nvSpPr>
+        <p:spPr>
+          <a:xfrm>
+            <a:off x="5505450" y="3170502"/>
+            <a:ext cx="10366031" cy="552053"/>
+          </a:xfrm>
+          <a:prstGeom prst="rect">
+            <a:avLst/>
+          </a:prstGeom>
+          <a:noFill/>
+          <a:ln/>
+        </p:spPr>
+        <p:txBody>
+          <a:bodyPr wrap="square" lIns="25400" tIns="25400" rIns="25400" bIns="25400" rtlCol="0" anchor="t">
+            <a:normAutofit/>
+          </a:bodyPr>
+          <a:lstStyle/>
+          <a:p>
+            <a:pPr algn="l" indent="0" marL="0">
+              <a:lnSpc>
+                <a:spcPct val="142000"/>
+              </a:lnSpc>
+              <a:buNone/>
+            </a:pPr>
+            <a:r>
+              <a:rPr lang="en-US" sz="2850" dirty="0">
+                <a:solidFill>
+                  <a:srgbClr val="384655"/>
+                </a:solidFill>
+                <a:latin typeface="Arial" pitchFamily="34" charset="0"/>
+                <a:ea typeface="Arial" pitchFamily="34" charset="-122"/>
+                <a:cs typeface="Arial" pitchFamily="34" charset="-120"/>
+              </a:rPr>
+              <a:t>Certificado com assinatura digital do instrutor.</a:t>
+            </a:r>
+            <a:endParaRPr lang="en-US" sz="2850" dirty="0"/>
+          </a:p>
+        </p:txBody>
+      </p:sp>
+      <p:sp>
+        <p:nvSpPr>
+          <p:cNvPr id="10" name="Shape 7"/>
+          <p:cNvSpPr/>
+          <p:nvPr/>
+        </p:nvSpPr>
+        <p:spPr>
+          <a:xfrm>
+            <a:off x="5048250" y="4141655"/>
+            <a:ext cx="209550" cy="209550"/>
+          </a:xfrm>
+          <a:prstGeom prst="rect">
+            <a:avLst/>
+          </a:prstGeom>
+          <a:solidFill>
+            <a:srgbClr val="F5B21A"/>
+          </a:solidFill>
+          <a:ln/>
+        </p:spPr>
+      </p:sp>
+      <p:sp>
+        <p:nvSpPr>
+          <p:cNvPr id="11" name="Text 8"/>
+          <p:cNvSpPr/>
+          <p:nvPr/>
+        </p:nvSpPr>
+        <p:spPr>
+          <a:xfrm>
+            <a:off x="5505450" y="4008305"/>
+            <a:ext cx="8202282" cy="552053"/>
+          </a:xfrm>
+          <a:prstGeom prst="rect">
+            <a:avLst/>
+          </a:prstGeom>
+          <a:noFill/>
+          <a:ln/>
+        </p:spPr>
+        <p:txBody>
+          <a:bodyPr wrap="square" lIns="25400" tIns="25400" rIns="25400" bIns="25400" rtlCol="0" anchor="t">
+            <a:normAutofit/>
+          </a:bodyPr>
+          <a:lstStyle/>
+          <a:p>
+            <a:pPr algn="l" indent="0" marL="0">
+              <a:lnSpc>
+                <a:spcPct val="142000"/>
+              </a:lnSpc>
+              <a:buNone/>
+            </a:pPr>
+            <a:r>
+              <a:rPr lang="en-US" sz="2850" dirty="0">
+                <a:solidFill>
+                  <a:srgbClr val="384655"/>
+                </a:solidFill>
+                <a:latin typeface="Arial" pitchFamily="34" charset="0"/>
+                <a:ea typeface="Arial" pitchFamily="34" charset="-122"/>
+                <a:cs typeface="Arial" pitchFamily="34" charset="-120"/>
+              </a:rPr>
+              <a:t>Prova corrigida no servidor + homologação.</a:t>
+            </a:r>
+            <a:endParaRPr lang="en-US" sz="2850" dirty="0"/>
+          </a:p>
+        </p:txBody>
+      </p:sp>
+      <p:sp>
+        <p:nvSpPr>
+          <p:cNvPr id="12" name="Shape 9"/>
+          <p:cNvSpPr/>
+          <p:nvPr/>
+        </p:nvSpPr>
+        <p:spPr>
+          <a:xfrm>
+            <a:off x="5048250" y="4979458"/>
+            <a:ext cx="209550" cy="209550"/>
+          </a:xfrm>
+          <a:prstGeom prst="rect">
+            <a:avLst/>
+          </a:prstGeom>
+          <a:solidFill>
+            <a:srgbClr val="F5B21A"/>
+          </a:solidFill>
+          <a:ln/>
+        </p:spPr>
+      </p:sp>
+      <p:sp>
+        <p:nvSpPr>
+          <p:cNvPr id="13" name="Text 10"/>
+          <p:cNvSpPr/>
+          <p:nvPr/>
+        </p:nvSpPr>
+        <p:spPr>
+          <a:xfrm>
+            <a:off x="5505450" y="4846108"/>
+            <a:ext cx="10095217" cy="552053"/>
+          </a:xfrm>
+          <a:prstGeom prst="rect">
+            <a:avLst/>
+          </a:prstGeom>
+          <a:noFill/>
+          <a:ln/>
+        </p:spPr>
+        <p:txBody>
+          <a:bodyPr wrap="square" lIns="25400" tIns="25400" rIns="25400" bIns="25400" rtlCol="0" anchor="t">
+            <a:normAutofit/>
+          </a:bodyPr>
+          <a:lstStyle/>
+          <a:p>
+            <a:pPr algn="l" indent="0" marL="0">
+              <a:lnSpc>
+                <a:spcPct val="142000"/>
+              </a:lnSpc>
+              <a:buNone/>
+            </a:pPr>
+            <a:r>
+              <a:rPr lang="en-US" sz="2850" dirty="0">
+                <a:solidFill>
+                  <a:srgbClr val="384655"/>
+                </a:solidFill>
+                <a:latin typeface="Arial" pitchFamily="34" charset="0"/>
+                <a:ea typeface="Arial" pitchFamily="34" charset="-122"/>
+                <a:cs typeface="Arial" pitchFamily="34" charset="-120"/>
+              </a:rPr>
+              <a:t>Multiplataforma: site, app Android e painel B2B.</a:t>
+            </a:r>
+            <a:endParaRPr lang="en-US" sz="2850" dirty="0"/>
+          </a:p>
+        </p:txBody>
+      </p:sp>
+      <p:sp>
+        <p:nvSpPr>
+          <p:cNvPr id="14" name="Text 11"/>
+          <p:cNvSpPr/>
+          <p:nvPr/>
+        </p:nvSpPr>
+        <p:spPr>
+          <a:xfrm>
+            <a:off x="5048250" y="9505950"/>
+            <a:ext cx="4603406" cy="285750"/>
+          </a:xfrm>
+          <a:prstGeom prst="rect">
+            <a:avLst/>
+          </a:prstGeom>
+          <a:noFill/>
+          <a:ln/>
+        </p:spPr>
+        <p:txBody>
+          <a:bodyPr wrap="square" lIns="25400" tIns="25400" rIns="25400" bIns="25400" rtlCol="0" anchor="t">
+            <a:normAutofit/>
+          </a:bodyPr>
+          <a:lstStyle/>
+          <a:p>
+            <a:pPr algn="l" indent="0" marL="0">
+              <a:lnSpc>
+                <a:spcPct val="100000"/>
+              </a:lnSpc>
+              <a:buNone/>
+            </a:pPr>
+            <a:r>
+              <a:rPr lang="en-US" sz="1950" b="1" dirty="0">
+                <a:solidFill>
+                  <a:srgbClr val="8A94A6"/>
+                </a:solidFill>
+                <a:latin typeface="Arial" pitchFamily="34" charset="0"/>
+                <a:ea typeface="Arial" pitchFamily="34" charset="-122"/>
+                <a:cs typeface="Arial" pitchFamily="34" charset="-120"/>
+              </a:rPr>
+              <a:t>FalaInstrutor · Segurança do Trabalho</a:t>
+            </a:r>
+            <a:endParaRPr lang="en-US" sz="1950" dirty="0"/>
+          </a:p>
+        </p:txBody>
+      </p:sp>
+      <p:sp>
+        <p:nvSpPr>
+          <p:cNvPr id="15" name="Text 12"/>
+          <p:cNvSpPr/>
+          <p:nvPr/>
+        </p:nvSpPr>
+        <p:spPr>
+          <a:xfrm>
+            <a:off x="17155187" y="9505950"/>
+            <a:ext cx="351764" cy="285750"/>
+          </a:xfrm>
+          <a:prstGeom prst="rect">
+            <a:avLst/>
+          </a:prstGeom>
+          <a:noFill/>
+          <a:ln/>
+        </p:spPr>
+        <p:txBody>
+          <a:bodyPr wrap="square" lIns="25400" tIns="25400" rIns="25400" bIns="25400" rtlCol="0" anchor="t">
+            <a:normAutofit/>
+          </a:bodyPr>
+          <a:lstStyle/>
+          <a:p>
+            <a:pPr algn="l" indent="0" marL="0">
+              <a:lnSpc>
+                <a:spcPct val="100000"/>
+              </a:lnSpc>
+              <a:buNone/>
+            </a:pPr>
+            <a:r>
+              <a:rPr lang="en-US" sz="1950" b="1" dirty="0">
+                <a:solidFill>
+                  <a:srgbClr val="8A94A6"/>
+                </a:solidFill>
+                <a:latin typeface="Arial" pitchFamily="34" charset="0"/>
+                <a:ea typeface="Arial" pitchFamily="34" charset="-122"/>
+                <a:cs typeface="Arial" pitchFamily="34" charset="-120"/>
+              </a:rPr>
+              <a:t>07</a:t>
             </a:r>
             <a:endParaRPr lang="en-US" sz="1950" dirty="0"/>
           </a:p>

</xml_diff>